<commit_message>
refactor: make the new theme the main kotonara template; keep the old one as nologo-2
- kotonara-brand-template.pptx is now the new theme (accent1 4D9622, ことテク logo, blank footer)
- kotonara-brand-template-nologo-1.pptx: same new theme without logos
- kotonara-brand-template-nologo-2.pptx: the previous main template, unchanged (git mv)
- Flatten kototech-theme/ into the repo root with kotonara naming:
  scripts/build_kotonara_theme_pptx.py (adds --no-logo and --build-templates),
  scripts/make_kotonara_logo.py, scripts/test_build_kotonara_theme_pptx.py,
  assets/kotonara-logo*.{svg,png}, kotonara-brand-template.md,
  examples/kotonara-calendar-sample.md
- scripts/build_kotonara_pptx.py now writes its template to nologo-2 so rerunning it
  no longer overwrites the main template
- README documents the three templates; hackathon-2026 is untouched

Co-Authored-By: Claude Opus 5.5 <noreply@anthropic.com>
Claude-Session: https://claude.ai/code/session_01M66qdQfBAyB1eMNb8z4rRo
</commit_message>
<xml_diff>
--- a/kotonara-brand-template.pptx
+++ b/kotonara-brand-template.pptx
@@ -9,6 +9,10 @@
   </p:notesMasterIdLst>
   <p:sldIdLst>
     <p:sldId id="256" r:id="rId7"/>
+    <p:sldId id="257" r:id="rId8"/>
+    <p:sldId id="258" r:id="rId9"/>
+    <p:sldId id="259" r:id="rId10"/>
+    <p:sldId id="260" r:id="rId11"/>
   </p:sldIdLst>
   <p:sldSz cx="12192000" cy="6858000"/>
   <p:notesSz cx="6858000" cy="9144000"/>
@@ -468,6 +472,381 @@
 </p:notesMaster>
 </file>
 
+<file path=ppt/notesSlides/notesSlide1.xml><?xml version="1.0" encoding="utf-8"?>
+<p:notes xmlns:a="http://schemas.openxmlformats.org/drawingml/2006/main" xmlns:p="http://schemas.openxmlformats.org/presentationml/2006/main" xmlns:r="http://schemas.openxmlformats.org/officeDocument/2006/relationships">
+  <p:cSld>
+    <p:spTree>
+      <p:nvGrpSpPr>
+        <p:cNvPr id="1" name=""/>
+        <p:cNvGrpSpPr/>
+        <p:nvPr/>
+      </p:nvGrpSpPr>
+      <p:grpSpPr>
+        <a:xfrm>
+          <a:off x="0" y="0"/>
+          <a:ext cx="0" cy="0"/>
+          <a:chOff x="0" y="0"/>
+          <a:chExt cx="0" cy="0"/>
+        </a:xfrm>
+      </p:grpSpPr>
+      <p:sp>
+        <p:nvSpPr>
+          <p:cNvPr id="2" name="Slide Image Placeholder 1"/>
+          <p:cNvSpPr>
+            <a:spLocks noGrp="1"/>
+          </p:cNvSpPr>
+          <p:nvPr>
+            <p:ph type="sldImg" idx="2"/>
+          </p:nvPr>
+        </p:nvSpPr>
+        <p:spPr/>
+      </p:sp>
+      <p:sp>
+        <p:nvSpPr>
+          <p:cNvPr id="3" name="Notes Placeholder 2"/>
+          <p:cNvSpPr>
+            <a:spLocks noGrp="1"/>
+          </p:cNvSpPr>
+          <p:nvPr>
+            <p:ph type="body" idx="3"/>
+          </p:nvPr>
+        </p:nvSpPr>
+        <p:spPr/>
+        <p:txBody>
+          <a:bodyPr/>
+          <a:lstStyle/>
+          <a:p>
+            <a:r>
+              <a:rPr sz="1200" lang="ja-JP" dirty="0">
+                <a:latin typeface="+mn-lt"/>
+                <a:ea typeface="+mn-ea"/>
+                <a:cs typeface="+mn-cs"/>
+              </a:rPr>
+              <a:t>表紙（タイトル）レイアウト。下部の帯にキャッチコピー『ひらめきを、カタチに。』が入る（ロゴ入りの雛形では帯の左に白いロゴ）。フッターは空欄。［挿入］＞［ヘッダーとフッター］で文言を入れられる。</a:t>
+            </a:r>
+          </a:p>
+        </p:txBody>
+      </p:sp>
+      <p:sp>
+        <p:nvSpPr>
+          <p:cNvPr id="4" name="Slide Number Placeholder 3"/>
+          <p:cNvSpPr>
+            <a:spLocks noGrp="1"/>
+          </p:cNvSpPr>
+          <p:nvPr>
+            <p:ph type="sldNum" idx="5" sz="quarter"/>
+          </p:nvPr>
+        </p:nvSpPr>
+        <p:spPr/>
+      </p:sp>
+    </p:spTree>
+  </p:cSld>
+  <p:clrMapOvr>
+    <a:masterClrMapping/>
+  </p:clrMapOvr>
+</p:notes>
+</file>
+
+<file path=ppt/notesSlides/notesSlide2.xml><?xml version="1.0" encoding="utf-8"?>
+<p:notes xmlns:a="http://schemas.openxmlformats.org/drawingml/2006/main" xmlns:p="http://schemas.openxmlformats.org/presentationml/2006/main" xmlns:r="http://schemas.openxmlformats.org/officeDocument/2006/relationships">
+  <p:cSld>
+    <p:spTree>
+      <p:nvGrpSpPr>
+        <p:cNvPr id="1" name=""/>
+        <p:cNvGrpSpPr/>
+        <p:nvPr/>
+      </p:nvGrpSpPr>
+      <p:grpSpPr>
+        <a:xfrm>
+          <a:off x="0" y="0"/>
+          <a:ext cx="0" cy="0"/>
+          <a:chOff x="0" y="0"/>
+          <a:chExt cx="0" cy="0"/>
+        </a:xfrm>
+      </p:grpSpPr>
+      <p:sp>
+        <p:nvSpPr>
+          <p:cNvPr id="2" name="Slide Image Placeholder 1"/>
+          <p:cNvSpPr>
+            <a:spLocks noGrp="1"/>
+          </p:cNvSpPr>
+          <p:nvPr>
+            <p:ph type="sldImg" idx="2"/>
+          </p:nvPr>
+        </p:nvSpPr>
+        <p:spPr/>
+      </p:sp>
+      <p:sp>
+        <p:nvSpPr>
+          <p:cNvPr id="3" name="Notes Placeholder 2"/>
+          <p:cNvSpPr>
+            <a:spLocks noGrp="1"/>
+          </p:cNvSpPr>
+          <p:nvPr>
+            <p:ph type="body" idx="3"/>
+          </p:nvPr>
+        </p:nvSpPr>
+        <p:spPr/>
+        <p:txBody>
+          <a:bodyPr/>
+          <a:lstStyle/>
+          <a:p>
+            <a:r>
+              <a:rPr sz="1200" lang="ja-JP" dirty="0">
+                <a:latin typeface="+mn-lt"/>
+                <a:ea typeface="+mn-ea"/>
+                <a:cs typeface="+mn-cs"/>
+              </a:rPr>
+              <a:t>タイトルとコンテンツ レイアウト。ロゴ入りの雛形では右上に緑のロゴ。</a:t>
+            </a:r>
+          </a:p>
+        </p:txBody>
+      </p:sp>
+      <p:sp>
+        <p:nvSpPr>
+          <p:cNvPr id="4" name="Slide Number Placeholder 3"/>
+          <p:cNvSpPr>
+            <a:spLocks noGrp="1"/>
+          </p:cNvSpPr>
+          <p:nvPr>
+            <p:ph type="sldNum" idx="5" sz="quarter"/>
+          </p:nvPr>
+        </p:nvSpPr>
+        <p:spPr/>
+      </p:sp>
+    </p:spTree>
+  </p:cSld>
+  <p:clrMapOvr>
+    <a:masterClrMapping/>
+  </p:clrMapOvr>
+</p:notes>
+</file>
+
+<file path=ppt/notesSlides/notesSlide3.xml><?xml version="1.0" encoding="utf-8"?>
+<p:notes xmlns:a="http://schemas.openxmlformats.org/drawingml/2006/main" xmlns:p="http://schemas.openxmlformats.org/presentationml/2006/main" xmlns:r="http://schemas.openxmlformats.org/officeDocument/2006/relationships">
+  <p:cSld>
+    <p:spTree>
+      <p:nvGrpSpPr>
+        <p:cNvPr id="1" name=""/>
+        <p:cNvGrpSpPr/>
+        <p:nvPr/>
+      </p:nvGrpSpPr>
+      <p:grpSpPr>
+        <a:xfrm>
+          <a:off x="0" y="0"/>
+          <a:ext cx="0" cy="0"/>
+          <a:chOff x="0" y="0"/>
+          <a:chExt cx="0" cy="0"/>
+        </a:xfrm>
+      </p:grpSpPr>
+      <p:sp>
+        <p:nvSpPr>
+          <p:cNvPr id="2" name="Slide Image Placeholder 1"/>
+          <p:cNvSpPr>
+            <a:spLocks noGrp="1"/>
+          </p:cNvSpPr>
+          <p:nvPr>
+            <p:ph type="sldImg" idx="2"/>
+          </p:nvPr>
+        </p:nvSpPr>
+        <p:spPr/>
+      </p:sp>
+      <p:sp>
+        <p:nvSpPr>
+          <p:cNvPr id="3" name="Notes Placeholder 2"/>
+          <p:cNvSpPr>
+            <a:spLocks noGrp="1"/>
+          </p:cNvSpPr>
+          <p:nvPr>
+            <p:ph type="body" idx="3"/>
+          </p:nvPr>
+        </p:nvSpPr>
+        <p:spPr/>
+        <p:txBody>
+          <a:bodyPr/>
+          <a:lstStyle/>
+          <a:p>
+            <a:r>
+              <a:rPr sz="1200" lang="ja-JP" dirty="0">
+                <a:latin typeface="+mn-lt"/>
+                <a:ea typeface="+mn-ea"/>
+                <a:cs typeface="+mn-cs"/>
+              </a:rPr>
+              <a:t>表スライド レイアウト。表はネイティブの表オブジェクト。ヘッダー行はメインの緑。</a:t>
+            </a:r>
+          </a:p>
+        </p:txBody>
+      </p:sp>
+      <p:sp>
+        <p:nvSpPr>
+          <p:cNvPr id="4" name="Slide Number Placeholder 3"/>
+          <p:cNvSpPr>
+            <a:spLocks noGrp="1"/>
+          </p:cNvSpPr>
+          <p:nvPr>
+            <p:ph type="sldNum" idx="5" sz="quarter"/>
+          </p:nvPr>
+        </p:nvSpPr>
+        <p:spPr/>
+      </p:sp>
+    </p:spTree>
+  </p:cSld>
+  <p:clrMapOvr>
+    <a:masterClrMapping/>
+  </p:clrMapOvr>
+</p:notes>
+</file>
+
+<file path=ppt/notesSlides/notesSlide4.xml><?xml version="1.0" encoding="utf-8"?>
+<p:notes xmlns:a="http://schemas.openxmlformats.org/drawingml/2006/main" xmlns:p="http://schemas.openxmlformats.org/presentationml/2006/main" xmlns:r="http://schemas.openxmlformats.org/officeDocument/2006/relationships">
+  <p:cSld>
+    <p:spTree>
+      <p:nvGrpSpPr>
+        <p:cNvPr id="1" name=""/>
+        <p:cNvGrpSpPr/>
+        <p:nvPr/>
+      </p:nvGrpSpPr>
+      <p:grpSpPr>
+        <a:xfrm>
+          <a:off x="0" y="0"/>
+          <a:ext cx="0" cy="0"/>
+          <a:chOff x="0" y="0"/>
+          <a:chExt cx="0" cy="0"/>
+        </a:xfrm>
+      </p:grpSpPr>
+      <p:sp>
+        <p:nvSpPr>
+          <p:cNvPr id="2" name="Slide Image Placeholder 1"/>
+          <p:cNvSpPr>
+            <a:spLocks noGrp="1"/>
+          </p:cNvSpPr>
+          <p:nvPr>
+            <p:ph type="sldImg" idx="2"/>
+          </p:nvPr>
+        </p:nvSpPr>
+        <p:spPr/>
+      </p:sp>
+      <p:sp>
+        <p:nvSpPr>
+          <p:cNvPr id="3" name="Notes Placeholder 2"/>
+          <p:cNvSpPr>
+            <a:spLocks noGrp="1"/>
+          </p:cNvSpPr>
+          <p:nvPr>
+            <p:ph type="body" idx="3"/>
+          </p:nvPr>
+        </p:nvSpPr>
+        <p:spPr/>
+        <p:txBody>
+          <a:bodyPr/>
+          <a:lstStyle/>
+          <a:p>
+            <a:r>
+              <a:rPr sz="1200" lang="ja-JP" dirty="0">
+                <a:latin typeface="+mn-lt"/>
+                <a:ea typeface="+mn-ea"/>
+                <a:cs typeface="+mn-cs"/>
+              </a:rPr>
+              <a:t>セクション見出し レイアウト。左に縦の緑のバー。</a:t>
+            </a:r>
+          </a:p>
+        </p:txBody>
+      </p:sp>
+      <p:sp>
+        <p:nvSpPr>
+          <p:cNvPr id="4" name="Slide Number Placeholder 3"/>
+          <p:cNvSpPr>
+            <a:spLocks noGrp="1"/>
+          </p:cNvSpPr>
+          <p:nvPr>
+            <p:ph type="sldNum" idx="5" sz="quarter"/>
+          </p:nvPr>
+        </p:nvSpPr>
+        <p:spPr/>
+      </p:sp>
+    </p:spTree>
+  </p:cSld>
+  <p:clrMapOvr>
+    <a:masterClrMapping/>
+  </p:clrMapOvr>
+</p:notes>
+</file>
+
+<file path=ppt/notesSlides/notesSlide5.xml><?xml version="1.0" encoding="utf-8"?>
+<p:notes xmlns:a="http://schemas.openxmlformats.org/drawingml/2006/main" xmlns:p="http://schemas.openxmlformats.org/presentationml/2006/main" xmlns:r="http://schemas.openxmlformats.org/officeDocument/2006/relationships">
+  <p:cSld>
+    <p:spTree>
+      <p:nvGrpSpPr>
+        <p:cNvPr id="1" name=""/>
+        <p:cNvGrpSpPr/>
+        <p:nvPr/>
+      </p:nvGrpSpPr>
+      <p:grpSpPr>
+        <a:xfrm>
+          <a:off x="0" y="0"/>
+          <a:ext cx="0" cy="0"/>
+          <a:chOff x="0" y="0"/>
+          <a:chExt cx="0" cy="0"/>
+        </a:xfrm>
+      </p:grpSpPr>
+      <p:sp>
+        <p:nvSpPr>
+          <p:cNvPr id="2" name="Slide Image Placeholder 1"/>
+          <p:cNvSpPr>
+            <a:spLocks noGrp="1"/>
+          </p:cNvSpPr>
+          <p:nvPr>
+            <p:ph type="sldImg" idx="2"/>
+          </p:nvPr>
+        </p:nvSpPr>
+        <p:spPr/>
+      </p:sp>
+      <p:sp>
+        <p:nvSpPr>
+          <p:cNvPr id="3" name="Notes Placeholder 2"/>
+          <p:cNvSpPr>
+            <a:spLocks noGrp="1"/>
+          </p:cNvSpPr>
+          <p:nvPr>
+            <p:ph type="body" idx="3"/>
+          </p:nvPr>
+        </p:nvSpPr>
+        <p:spPr/>
+        <p:txBody>
+          <a:bodyPr/>
+          <a:lstStyle/>
+          <a:p>
+            <a:r>
+              <a:rPr sz="1200" lang="ja-JP" dirty="0">
+                <a:latin typeface="+mn-lt"/>
+                <a:ea typeface="+mn-ea"/>
+                <a:cs typeface="+mn-cs"/>
+              </a:rPr>
+              <a:t>クロージング（反転）レイアウト。背景がメインの緑で、ロゴは入らない。</a:t>
+            </a:r>
+          </a:p>
+        </p:txBody>
+      </p:sp>
+      <p:sp>
+        <p:nvSpPr>
+          <p:cNvPr id="4" name="Slide Number Placeholder 3"/>
+          <p:cNvSpPr>
+            <a:spLocks noGrp="1"/>
+          </p:cNvSpPr>
+          <p:nvPr>
+            <p:ph type="sldNum" idx="5" sz="quarter"/>
+          </p:nvPr>
+        </p:nvSpPr>
+        <p:spPr/>
+      </p:sp>
+    </p:spTree>
+  </p:cSld>
+  <p:clrMapOvr>
+    <a:masterClrMapping/>
+  </p:clrMapOvr>
+</p:notes>
+</file>
+
 <file path=ppt/slideLayouts/slideLayout1.xml><?xml version="1.0" encoding="utf-8"?>
 <p:sldLayout xmlns:a="http://schemas.openxmlformats.org/drawingml/2006/main" xmlns:r="http://schemas.openxmlformats.org/officeDocument/2006/relationships" xmlns:p="http://schemas.openxmlformats.org/presentationml/2006/main" type="title" preserve="1">
   <p:cSld name="表紙（タイトル）">
@@ -507,12 +886,12 @@
           </a:ln>
         </p:spPr>
         <p:txBody>
-          <a:bodyPr lIns="761695" tIns="0" rIns="761695" bIns="0" anchor="ctr"/>
+          <a:bodyPr lIns="2557751" tIns="0" rIns="761695" bIns="182423" anchor="b"/>
           <a:lstStyle/>
           <a:p>
             <a:pPr algn="l"/>
             <a:r>
-              <a:rPr lang="ja-JP" sz="1500" b="1" spc="300" dirty="0">
+              <a:rPr lang="ja-JP" sz="1300" b="1" spc="300" dirty="0">
                 <a:solidFill>
                   <a:schemeClr val="bg1"/>
                 </a:solidFill>
@@ -757,6 +1136,36 @@
           <a:p/>
         </p:txBody>
       </p:sp>
+      <p:pic>
+        <p:nvPicPr>
+          <p:cNvPr id="7" name="ことテク ロゴ" descr="ことテク"/>
+          <p:cNvPicPr>
+            <a:picLocks noChangeAspect="1"/>
+          </p:cNvPicPr>
+          <p:nvPr/>
+        </p:nvPicPr>
+        <p:blipFill>
+          <a:blip r:embed="rId2">
+            <a:extLst>
+              <a:ext uri="{96DAC541-7B7A-43D3-8B79-37D633B846F1}">
+                <asvg:svgBlip xmlns:asvg="http://schemas.microsoft.com/office/drawing/2016/SVG/main" r:embed="rId3"/>
+              </a:ext>
+            </a:extLst>
+          </a:blip>
+          <a:stretch>
+            <a:fillRect/>
+          </a:stretch>
+        </p:blipFill>
+        <p:spPr>
+          <a:xfrm>
+            <a:off x="761695" y="6080303"/>
+            <a:ext cx="1686328" cy="595274"/>
+          </a:xfrm>
+          <a:prstGeom prst="rect">
+            <a:avLst/>
+          </a:prstGeom>
+        </p:spPr>
+      </p:pic>
     </p:spTree>
   </p:cSld>
   <p:clrMapOvr>
@@ -1042,7 +1451,7 @@
           <a:p>
             <a:r>
               <a:rPr lang="ja-JP" dirty="0"/>
-              <a:t>ことテク2026 2daysハッカソン</a:t>
+              <a:t/>
             </a:r>
             <a:endParaRPr lang="ja-JP" dirty="0"/>
           </a:p>
@@ -1120,6 +1529,36 @@
           </a:p>
         </p:txBody>
       </p:sp>
+      <p:pic>
+        <p:nvPicPr>
+          <p:cNvPr id="8" name="ことテク ロゴ" descr="ことテク"/>
+          <p:cNvPicPr>
+            <a:picLocks noChangeAspect="1"/>
+          </p:cNvPicPr>
+          <p:nvPr/>
+        </p:nvPicPr>
+        <p:blipFill>
+          <a:blip r:embed="rId2">
+            <a:extLst>
+              <a:ext uri="{96DAC541-7B7A-43D3-8B79-37D633B846F1}">
+                <asvg:svgBlip xmlns:asvg="http://schemas.microsoft.com/office/drawing/2016/SVG/main" r:embed="rId3"/>
+              </a:ext>
+            </a:extLst>
+          </a:blip>
+          <a:stretch>
+            <a:fillRect/>
+          </a:stretch>
+        </p:blipFill>
+        <p:spPr>
+          <a:xfrm>
+            <a:off x="10135121" y="365760"/>
+            <a:ext cx="1295184" cy="457200"/>
+          </a:xfrm>
+          <a:prstGeom prst="rect">
+            <a:avLst/>
+          </a:prstGeom>
+        </p:spPr>
+      </p:pic>
     </p:spTree>
   </p:cSld>
   <p:clrMapOvr>
@@ -1333,7 +1772,7 @@
           <a:p>
             <a:r>
               <a:rPr lang="ja-JP" dirty="0"/>
-              <a:t>ことテク2026 2daysハッカソン</a:t>
+              <a:t/>
             </a:r>
             <a:endParaRPr lang="ja-JP" dirty="0"/>
           </a:p>
@@ -1411,6 +1850,36 @@
           </a:p>
         </p:txBody>
       </p:sp>
+      <p:pic>
+        <p:nvPicPr>
+          <p:cNvPr id="7" name="ことテク ロゴ" descr="ことテク"/>
+          <p:cNvPicPr>
+            <a:picLocks noChangeAspect="1"/>
+          </p:cNvPicPr>
+          <p:nvPr/>
+        </p:nvPicPr>
+        <p:blipFill>
+          <a:blip r:embed="rId2">
+            <a:extLst>
+              <a:ext uri="{96DAC541-7B7A-43D3-8B79-37D633B846F1}">
+                <asvg:svgBlip xmlns:asvg="http://schemas.microsoft.com/office/drawing/2016/SVG/main" r:embed="rId3"/>
+              </a:ext>
+            </a:extLst>
+          </a:blip>
+          <a:stretch>
+            <a:fillRect/>
+          </a:stretch>
+        </p:blipFill>
+        <p:spPr>
+          <a:xfrm>
+            <a:off x="10135121" y="365760"/>
+            <a:ext cx="1295184" cy="457200"/>
+          </a:xfrm>
+          <a:prstGeom prst="rect">
+            <a:avLst/>
+          </a:prstGeom>
+        </p:spPr>
+      </p:pic>
     </p:spTree>
   </p:cSld>
   <p:clrMapOvr>
@@ -1696,7 +2165,7 @@
           <a:p>
             <a:r>
               <a:rPr lang="ja-JP" dirty="0"/>
-              <a:t>ことテク2026 2daysハッカソン</a:t>
+              <a:t/>
             </a:r>
             <a:endParaRPr lang="ja-JP" dirty="0"/>
           </a:p>
@@ -1774,6 +2243,36 @@
           </a:p>
         </p:txBody>
       </p:sp>
+      <p:pic>
+        <p:nvPicPr>
+          <p:cNvPr id="8" name="ことテク ロゴ" descr="ことテク"/>
+          <p:cNvPicPr>
+            <a:picLocks noChangeAspect="1"/>
+          </p:cNvPicPr>
+          <p:nvPr/>
+        </p:nvPicPr>
+        <p:blipFill>
+          <a:blip r:embed="rId2">
+            <a:extLst>
+              <a:ext uri="{96DAC541-7B7A-43D3-8B79-37D633B846F1}">
+                <asvg:svgBlip xmlns:asvg="http://schemas.microsoft.com/office/drawing/2016/SVG/main" r:embed="rId3"/>
+              </a:ext>
+            </a:extLst>
+          </a:blip>
+          <a:stretch>
+            <a:fillRect/>
+          </a:stretch>
+        </p:blipFill>
+        <p:spPr>
+          <a:xfrm>
+            <a:off x="10135121" y="365760"/>
+            <a:ext cx="1295184" cy="457200"/>
+          </a:xfrm>
+          <a:prstGeom prst="rect">
+            <a:avLst/>
+          </a:prstGeom>
+        </p:spPr>
+      </p:pic>
     </p:spTree>
   </p:cSld>
   <p:clrMapOvr>
@@ -2049,7 +2548,7 @@
           <a:p>
             <a:r>
               <a:rPr lang="ja-JP" dirty="0"/>
-              <a:t>ことテク2026 2daysハッカソン</a:t>
+              <a:t/>
             </a:r>
             <a:endParaRPr lang="ja-JP" dirty="0"/>
           </a:p>
@@ -2406,7 +2905,7 @@
           <a:p>
             <a:r>
               <a:rPr lang="ja-JP" dirty="0"/>
-              <a:t>ことテク2026 2daysハッカソン</a:t>
+              <a:t/>
             </a:r>
             <a:endParaRPr lang="ja-JP" dirty="0"/>
           </a:p>
@@ -2913,6 +3412,1406 @@
 </p:sld>
 </file>
 
+<file path=ppt/slides/slide2.xml><?xml version="1.0" encoding="utf-8"?>
+<p:sld xmlns:a="http://schemas.openxmlformats.org/drawingml/2006/main" xmlns:p="http://schemas.openxmlformats.org/presentationml/2006/main" xmlns:r="http://schemas.openxmlformats.org/officeDocument/2006/relationships">
+  <p:cSld>
+    <p:spTree>
+      <p:nvGrpSpPr>
+        <p:cNvPr id="1" name=""/>
+        <p:cNvGrpSpPr/>
+        <p:nvPr/>
+      </p:nvGrpSpPr>
+      <p:grpSpPr/>
+      <p:sp>
+        <p:nvSpPr>
+          <p:cNvPr id="2" name="Title 1"/>
+          <p:cNvSpPr>
+            <a:spLocks noGrp="1"/>
+          </p:cNvSpPr>
+          <p:nvPr>
+            <p:ph type="title"/>
+          </p:nvPr>
+        </p:nvSpPr>
+        <p:spPr/>
+        <p:txBody>
+          <a:bodyPr/>
+          <a:lstStyle/>
+          <a:p>
+            <a:r>
+              <a:rPr lang="ja-JP" dirty="0">
+                <a:latin typeface="+mj-lt"/>
+                <a:ea typeface="+mj-ea"/>
+                <a:cs typeface="+mj-cs"/>
+              </a:rPr>
+              <a:t>タイトルとコンテンツ</a:t>
+            </a:r>
+          </a:p>
+        </p:txBody>
+      </p:sp>
+      <p:sp>
+        <p:nvSpPr>
+          <p:cNvPr id="3" name="Text Placeholder 2"/>
+          <p:cNvSpPr>
+            <a:spLocks noGrp="1"/>
+          </p:cNvSpPr>
+          <p:nvPr>
+            <p:ph type="body" idx="1"/>
+          </p:nvPr>
+        </p:nvSpPr>
+        <p:spPr/>
+        <p:txBody>
+          <a:bodyPr/>
+          <a:lstStyle/>
+          <a:p>
+            <a:pPr/>
+            <a:r>
+              <a:rPr sz="2000" lang="ja-JP" dirty="0">
+                <a:latin typeface="+mn-lt"/>
+                <a:ea typeface="+mn-ea"/>
+                <a:cs typeface="+mn-cs"/>
+              </a:rPr>
+              <a:t>本文は箇条書きで書きます</a:t>
+            </a:r>
+          </a:p>
+          <a:p>
+            <a:pPr/>
+            <a:r>
+              <a:rPr sz="2000" lang="ja-JP" dirty="0">
+                <a:latin typeface="+mn-lt"/>
+                <a:ea typeface="+mn-ea"/>
+                <a:cs typeface="+mn-cs"/>
+              </a:rPr>
+              <a:t>1枚に6項目まで、1項目40字前後までが目安です</a:t>
+            </a:r>
+          </a:p>
+          <a:p>
+            <a:pPr lvl="1"/>
+            <a:r>
+              <a:rPr sz="2000" lang="ja-JP" dirty="0">
+                <a:latin typeface="+mn-lt"/>
+                <a:ea typeface="+mn-ea"/>
+                <a:cs typeface="+mn-cs"/>
+              </a:rPr>
+              <a:t>2段目の箇条書き</a:t>
+            </a:r>
+          </a:p>
+          <a:p>
+            <a:pPr/>
+            <a:r>
+              <a:rPr sz="2000" lang="ja-JP" dirty="0">
+                <a:latin typeface="+mn-lt"/>
+                <a:ea typeface="+mn-ea"/>
+                <a:cs typeface="+mn-cs"/>
+              </a:rPr>
+              <a:t>配色・フォントはテーマ、ロゴはレイアウトに入っています</a:t>
+            </a:r>
+          </a:p>
+        </p:txBody>
+      </p:sp>
+      <p:sp>
+        <p:nvSpPr>
+          <p:cNvPr id="4" name="Footer Placeholder"/>
+          <p:cNvSpPr>
+            <a:spLocks noGrp="1"/>
+          </p:cNvSpPr>
+          <p:nvPr>
+            <p:ph type="ftr" sz="quarter" idx="11"/>
+          </p:nvPr>
+        </p:nvSpPr>
+        <p:spPr>
+          <a:xfrm>
+            <a:off x="761695" y="6172200"/>
+            <a:ext cx="6400800" cy="274320"/>
+          </a:xfrm>
+          <a:prstGeom prst="rect">
+            <a:avLst/>
+          </a:prstGeom>
+        </p:spPr>
+        <p:txBody>
+          <a:bodyPr vert="horz" lIns="0" tIns="0" rIns="0" bIns="0" anchor="ctr"/>
+          <a:lstStyle>
+            <a:lvl1pPr marL="0" indent="0" algn="l">
+              <a:lnSpc>
+                <a:spcPct val="112000"/>
+              </a:lnSpc>
+              <a:spcBef>
+                <a:spcPts val="0"/>
+              </a:spcBef>
+              <a:buNone/>
+              <a:defRPr sz="1000" b="0" kern="1200" spc="60">
+                <a:solidFill>
+                  <a:schemeClr val="accent6"/>
+                </a:solidFill>
+                <a:latin typeface="+mn-lt"/>
+                <a:ea typeface="+mn-ea"/>
+                <a:cs typeface="+mn-cs"/>
+              </a:defRPr>
+            </a:lvl1pPr>
+            <a:lvl2pPr marL="400050" indent="-285750" algn="l">
+              <a:lnSpc>
+                <a:spcPct val="112000"/>
+              </a:lnSpc>
+              <a:spcBef>
+                <a:spcPts val="600"/>
+              </a:spcBef>
+              <a:buClr>
+                <a:schemeClr val="accent6"/>
+              </a:buClr>
+              <a:buSzPct val="90000"/>
+              <a:buFont typeface="Arial" panose="020B0604020202020204" pitchFamily="34" charset="0"/>
+              <a:buChar char="–"/>
+              <a:defRPr sz="1000" b="0" kern="1200">
+                <a:solidFill>
+                  <a:schemeClr val="accent6"/>
+                </a:solidFill>
+                <a:latin typeface="+mn-lt"/>
+                <a:ea typeface="+mn-ea"/>
+                <a:cs typeface="+mn-cs"/>
+              </a:defRPr>
+            </a:lvl2pPr>
+          </a:lstStyle>
+          <a:p>
+            <a:r>
+              <a:rPr lang="ja-JP" dirty="0"/>
+              <a:t/>
+            </a:r>
+            <a:endParaRPr lang="ja-JP" dirty="0"/>
+          </a:p>
+        </p:txBody>
+      </p:sp>
+      <p:sp>
+        <p:nvSpPr>
+          <p:cNvPr id="5" name="Slide Number Placeholder"/>
+          <p:cNvSpPr>
+            <a:spLocks noGrp="1"/>
+          </p:cNvSpPr>
+          <p:nvPr>
+            <p:ph type="sldNum" sz="quarter" idx="12"/>
+          </p:nvPr>
+        </p:nvSpPr>
+        <p:spPr>
+          <a:xfrm>
+            <a:off x="10515905" y="6172200"/>
+            <a:ext cx="914400" cy="274320"/>
+          </a:xfrm>
+          <a:prstGeom prst="rect">
+            <a:avLst/>
+          </a:prstGeom>
+        </p:spPr>
+        <p:txBody>
+          <a:bodyPr vert="horz" lIns="0" tIns="0" rIns="0" bIns="0" anchor="ctr"/>
+          <a:lstStyle>
+            <a:lvl1pPr marL="0" indent="0" algn="r">
+              <a:lnSpc>
+                <a:spcPct val="112000"/>
+              </a:lnSpc>
+              <a:spcBef>
+                <a:spcPts val="0"/>
+              </a:spcBef>
+              <a:buNone/>
+              <a:defRPr sz="1000" b="0" kern="1200">
+                <a:solidFill>
+                  <a:schemeClr val="accent6"/>
+                </a:solidFill>
+                <a:latin typeface="+mn-lt"/>
+                <a:ea typeface="+mn-ea"/>
+                <a:cs typeface="+mn-cs"/>
+              </a:defRPr>
+            </a:lvl1pPr>
+            <a:lvl2pPr marL="400050" indent="-285750" algn="r">
+              <a:lnSpc>
+                <a:spcPct val="112000"/>
+              </a:lnSpc>
+              <a:spcBef>
+                <a:spcPts val="600"/>
+              </a:spcBef>
+              <a:buClr>
+                <a:schemeClr val="accent6"/>
+              </a:buClr>
+              <a:buSzPct val="90000"/>
+              <a:buFont typeface="Arial" panose="020B0604020202020204" pitchFamily="34" charset="0"/>
+              <a:buChar char="–"/>
+              <a:defRPr sz="1000" b="0" kern="1200">
+                <a:solidFill>
+                  <a:schemeClr val="accent6"/>
+                </a:solidFill>
+                <a:latin typeface="+mn-lt"/>
+                <a:ea typeface="+mn-ea"/>
+                <a:cs typeface="+mn-cs"/>
+              </a:defRPr>
+            </a:lvl2pPr>
+          </a:lstStyle>
+          <a:p>
+            <a:pPr algn="r"/>
+            <a:fld id="{DE9A24DF-DA9C-4F13-B2E9-9B47BB328A49}" type="slidenum">
+              <a:rPr lang="ja-JP" smtClean="0"/>
+              <a:t>2</a:t>
+            </a:fld>
+            <a:endParaRPr lang="ja-JP" dirty="0"/>
+          </a:p>
+        </p:txBody>
+      </p:sp>
+    </p:spTree>
+  </p:cSld>
+  <p:clrMapOvr>
+    <a:masterClrMapping/>
+  </p:clrMapOvr>
+</p:sld>
+</file>
+
+<file path=ppt/slides/slide3.xml><?xml version="1.0" encoding="utf-8"?>
+<p:sld xmlns:a="http://schemas.openxmlformats.org/drawingml/2006/main" xmlns:p="http://schemas.openxmlformats.org/presentationml/2006/main" xmlns:r="http://schemas.openxmlformats.org/officeDocument/2006/relationships">
+  <p:cSld>
+    <p:spTree>
+      <p:nvGrpSpPr>
+        <p:cNvPr id="1" name=""/>
+        <p:cNvGrpSpPr/>
+        <p:nvPr/>
+      </p:nvGrpSpPr>
+      <p:grpSpPr/>
+      <p:sp>
+        <p:nvSpPr>
+          <p:cNvPr id="2" name="Title 1"/>
+          <p:cNvSpPr>
+            <a:spLocks noGrp="1"/>
+          </p:cNvSpPr>
+          <p:nvPr>
+            <p:ph type="title"/>
+          </p:nvPr>
+        </p:nvSpPr>
+        <p:spPr/>
+        <p:txBody>
+          <a:bodyPr/>
+          <a:lstStyle/>
+          <a:p>
+            <a:r>
+              <a:rPr lang="ja-JP" dirty="0">
+                <a:latin typeface="+mj-lt"/>
+                <a:ea typeface="+mj-ea"/>
+                <a:cs typeface="+mj-cs"/>
+              </a:rPr>
+              <a:t>表スライド</a:t>
+            </a:r>
+          </a:p>
+        </p:txBody>
+      </p:sp>
+      <p:graphicFrame>
+        <p:nvGraphicFramePr>
+          <p:cNvPr id="3" name="Table 2"/>
+          <p:cNvGraphicFramePr>
+            <a:graphicFrameLocks noGrp="1"/>
+          </p:cNvGraphicFramePr>
+          <p:nvPr/>
+        </p:nvGraphicFramePr>
+        <p:xfrm>
+          <a:off x="761695" y="1828800"/>
+          <a:ext cx="10668610" cy="1572768"/>
+        </p:xfrm>
+        <a:graphic>
+          <a:graphicData uri="http://schemas.openxmlformats.org/drawingml/2006/table">
+            <a:tbl>
+              <a:tblPr>
+                <a:tableStyleId>{5C22544A-7EE6-4342-B048-85BDC9FD1C3A}</a:tableStyleId>
+              </a:tblPr>
+              <a:tblGrid>
+                <a:gridCol w="2743200"/>
+                <a:gridCol w="7925410"/>
+              </a:tblGrid>
+              <a:tr h="420624">
+                <a:tc>
+                  <a:txBody>
+                    <a:bodyPr/>
+                    <a:lstStyle/>
+                    <a:p>
+                      <a:pPr marL="0" indent="0">
+                        <a:buNone/>
+                      </a:pPr>
+                      <a:r>
+                        <a:rPr sz="1500" b="1" lang="ja-JP" dirty="0">
+                          <a:solidFill>
+                            <a:schemeClr val="bg1"/>
+                          </a:solidFill>
+                          <a:latin typeface="+mn-lt"/>
+                          <a:ea typeface="+mn-ea"/>
+                          <a:cs typeface="+mn-cs"/>
+                        </a:rPr>
+                        <a:t>項目</a:t>
+                      </a:r>
+                    </a:p>
+                  </a:txBody>
+                  <a:tcPr marL="146304" marR="146304" marT="36576" marB="36576" anchor="ctr">
+                    <a:lnL w="9525" cap="flat" cmpd="sng" algn="ctr">
+                      <a:noFill/>
+                      <a:prstDash val="solid"/>
+                      <a:round/>
+                      <a:headEnd type="none" w="med" len="med"/>
+                      <a:tailEnd type="none" w="med" len="med"/>
+                    </a:lnL>
+                    <a:lnR w="9525" cap="flat" cmpd="sng" algn="ctr">
+                      <a:noFill/>
+                      <a:prstDash val="solid"/>
+                      <a:round/>
+                      <a:headEnd type="none" w="med" len="med"/>
+                      <a:tailEnd type="none" w="med" len="med"/>
+                    </a:lnR>
+                    <a:lnT w="9525" cap="flat" cmpd="sng" algn="ctr">
+                      <a:solidFill>
+                        <a:schemeClr val="accent1"/>
+                      </a:solidFill>
+                      <a:prstDash val="solid"/>
+                      <a:round/>
+                      <a:headEnd type="none" w="med" len="med"/>
+                      <a:tailEnd type="none" w="med" len="med"/>
+                    </a:lnT>
+                    <a:lnB w="9525" cap="flat" cmpd="sng" algn="ctr">
+                      <a:solidFill>
+                        <a:schemeClr val="accent1"/>
+                      </a:solidFill>
+                      <a:prstDash val="solid"/>
+                      <a:round/>
+                      <a:headEnd type="none" w="med" len="med"/>
+                      <a:tailEnd type="none" w="med" len="med"/>
+                    </a:lnB>
+                    <a:solidFill>
+                      <a:schemeClr val="accent1"/>
+                    </a:solidFill>
+                  </a:tcPr>
+                </a:tc>
+                <a:tc>
+                  <a:txBody>
+                    <a:bodyPr/>
+                    <a:lstStyle/>
+                    <a:p>
+                      <a:pPr marL="0" indent="0">
+                        <a:buNone/>
+                      </a:pPr>
+                      <a:r>
+                        <a:rPr sz="1500" b="1" lang="ja-JP" dirty="0">
+                          <a:solidFill>
+                            <a:schemeClr val="bg1"/>
+                          </a:solidFill>
+                          <a:latin typeface="+mn-lt"/>
+                          <a:ea typeface="+mn-ea"/>
+                          <a:cs typeface="+mn-cs"/>
+                        </a:rPr>
+                        <a:t>内容</a:t>
+                      </a:r>
+                    </a:p>
+                  </a:txBody>
+                  <a:tcPr marL="146304" marR="146304" marT="36576" marB="36576" anchor="ctr">
+                    <a:lnL w="9525" cap="flat" cmpd="sng" algn="ctr">
+                      <a:noFill/>
+                      <a:prstDash val="solid"/>
+                      <a:round/>
+                      <a:headEnd type="none" w="med" len="med"/>
+                      <a:tailEnd type="none" w="med" len="med"/>
+                    </a:lnL>
+                    <a:lnR w="9525" cap="flat" cmpd="sng" algn="ctr">
+                      <a:noFill/>
+                      <a:prstDash val="solid"/>
+                      <a:round/>
+                      <a:headEnd type="none" w="med" len="med"/>
+                      <a:tailEnd type="none" w="med" len="med"/>
+                    </a:lnR>
+                    <a:lnT w="9525" cap="flat" cmpd="sng" algn="ctr">
+                      <a:solidFill>
+                        <a:schemeClr val="accent1"/>
+                      </a:solidFill>
+                      <a:prstDash val="solid"/>
+                      <a:round/>
+                      <a:headEnd type="none" w="med" len="med"/>
+                      <a:tailEnd type="none" w="med" len="med"/>
+                    </a:lnT>
+                    <a:lnB w="9525" cap="flat" cmpd="sng" algn="ctr">
+                      <a:solidFill>
+                        <a:schemeClr val="accent1"/>
+                      </a:solidFill>
+                      <a:prstDash val="solid"/>
+                      <a:round/>
+                      <a:headEnd type="none" w="med" len="med"/>
+                      <a:tailEnd type="none" w="med" len="med"/>
+                    </a:lnB>
+                    <a:solidFill>
+                      <a:schemeClr val="accent1"/>
+                    </a:solidFill>
+                  </a:tcPr>
+                </a:tc>
+              </a:tr>
+              <a:tr h="384048">
+                <a:tc>
+                  <a:txBody>
+                    <a:bodyPr/>
+                    <a:lstStyle/>
+                    <a:p>
+                      <a:pPr marL="0" indent="0">
+                        <a:buNone/>
+                      </a:pPr>
+                      <a:r>
+                        <a:rPr sz="1400" b="1" lang="ja-JP" dirty="0">
+                          <a:solidFill>
+                            <a:schemeClr val="accent1"/>
+                          </a:solidFill>
+                          <a:latin typeface="+mn-lt"/>
+                          <a:ea typeface="+mn-ea"/>
+                          <a:cs typeface="+mn-cs"/>
+                        </a:rPr>
+                        <a:t>1列目</a:t>
+                      </a:r>
+                    </a:p>
+                  </a:txBody>
+                  <a:tcPr marL="146304" marR="146304" marT="36576" marB="36576" anchor="ctr">
+                    <a:lnL w="9525" cap="flat" cmpd="sng" algn="ctr">
+                      <a:noFill/>
+                      <a:prstDash val="solid"/>
+                      <a:round/>
+                      <a:headEnd type="none" w="med" len="med"/>
+                      <a:tailEnd type="none" w="med" len="med"/>
+                    </a:lnL>
+                    <a:lnR w="9525" cap="flat" cmpd="sng" algn="ctr">
+                      <a:noFill/>
+                      <a:prstDash val="solid"/>
+                      <a:round/>
+                      <a:headEnd type="none" w="med" len="med"/>
+                      <a:tailEnd type="none" w="med" len="med"/>
+                    </a:lnR>
+                    <a:lnT w="9525" cap="flat" cmpd="sng" algn="ctr">
+                      <a:solidFill>
+                        <a:schemeClr val="accent6">
+                          <a:alpha val="25000"/>
+                        </a:schemeClr>
+                      </a:solidFill>
+                      <a:prstDash val="solid"/>
+                      <a:round/>
+                      <a:headEnd type="none" w="med" len="med"/>
+                      <a:tailEnd type="none" w="med" len="med"/>
+                    </a:lnT>
+                    <a:lnB w="9525" cap="flat" cmpd="sng" algn="ctr">
+                      <a:solidFill>
+                        <a:schemeClr val="accent6">
+                          <a:alpha val="25000"/>
+                        </a:schemeClr>
+                      </a:solidFill>
+                      <a:prstDash val="solid"/>
+                      <a:round/>
+                      <a:headEnd type="none" w="med" len="med"/>
+                      <a:tailEnd type="none" w="med" len="med"/>
+                    </a:lnB>
+                    <a:solidFill>
+                      <a:schemeClr val="bg1"/>
+                    </a:solidFill>
+                  </a:tcPr>
+                </a:tc>
+                <a:tc>
+                  <a:txBody>
+                    <a:bodyPr/>
+                    <a:lstStyle/>
+                    <a:p>
+                      <a:pPr marL="0" indent="0">
+                        <a:buNone/>
+                      </a:pPr>
+                      <a:r>
+                        <a:rPr sz="1400" lang="ja-JP" dirty="0">
+                          <a:solidFill>
+                            <a:schemeClr val="tx2"/>
+                          </a:solidFill>
+                          <a:latin typeface="+mn-lt"/>
+                          <a:ea typeface="+mn-ea"/>
+                          <a:cs typeface="+mn-cs"/>
+                        </a:rPr>
+                        <a:t>太字・緑で表示されます</a:t>
+                      </a:r>
+                    </a:p>
+                  </a:txBody>
+                  <a:tcPr marL="146304" marR="146304" marT="36576" marB="36576" anchor="ctr">
+                    <a:lnL w="9525" cap="flat" cmpd="sng" algn="ctr">
+                      <a:noFill/>
+                      <a:prstDash val="solid"/>
+                      <a:round/>
+                      <a:headEnd type="none" w="med" len="med"/>
+                      <a:tailEnd type="none" w="med" len="med"/>
+                    </a:lnL>
+                    <a:lnR w="9525" cap="flat" cmpd="sng" algn="ctr">
+                      <a:noFill/>
+                      <a:prstDash val="solid"/>
+                      <a:round/>
+                      <a:headEnd type="none" w="med" len="med"/>
+                      <a:tailEnd type="none" w="med" len="med"/>
+                    </a:lnR>
+                    <a:lnT w="9525" cap="flat" cmpd="sng" algn="ctr">
+                      <a:solidFill>
+                        <a:schemeClr val="accent6">
+                          <a:alpha val="25000"/>
+                        </a:schemeClr>
+                      </a:solidFill>
+                      <a:prstDash val="solid"/>
+                      <a:round/>
+                      <a:headEnd type="none" w="med" len="med"/>
+                      <a:tailEnd type="none" w="med" len="med"/>
+                    </a:lnT>
+                    <a:lnB w="9525" cap="flat" cmpd="sng" algn="ctr">
+                      <a:solidFill>
+                        <a:schemeClr val="accent6">
+                          <a:alpha val="25000"/>
+                        </a:schemeClr>
+                      </a:solidFill>
+                      <a:prstDash val="solid"/>
+                      <a:round/>
+                      <a:headEnd type="none" w="med" len="med"/>
+                      <a:tailEnd type="none" w="med" len="med"/>
+                    </a:lnB>
+                    <a:solidFill>
+                      <a:schemeClr val="bg1"/>
+                    </a:solidFill>
+                  </a:tcPr>
+                </a:tc>
+              </a:tr>
+              <a:tr h="384048">
+                <a:tc>
+                  <a:txBody>
+                    <a:bodyPr/>
+                    <a:lstStyle/>
+                    <a:p>
+                      <a:pPr marL="0" indent="0">
+                        <a:buNone/>
+                      </a:pPr>
+                      <a:r>
+                        <a:rPr sz="1400" b="1" lang="ja-JP" dirty="0">
+                          <a:solidFill>
+                            <a:schemeClr val="accent1"/>
+                          </a:solidFill>
+                          <a:latin typeface="+mn-lt"/>
+                          <a:ea typeface="+mn-ea"/>
+                          <a:cs typeface="+mn-cs"/>
+                        </a:rPr>
+                        <a:t>2列目</a:t>
+                      </a:r>
+                    </a:p>
+                  </a:txBody>
+                  <a:tcPr marL="146304" marR="146304" marT="36576" marB="36576" anchor="ctr">
+                    <a:lnL w="9525" cap="flat" cmpd="sng" algn="ctr">
+                      <a:noFill/>
+                      <a:prstDash val="solid"/>
+                      <a:round/>
+                      <a:headEnd type="none" w="med" len="med"/>
+                      <a:tailEnd type="none" w="med" len="med"/>
+                    </a:lnL>
+                    <a:lnR w="9525" cap="flat" cmpd="sng" algn="ctr">
+                      <a:noFill/>
+                      <a:prstDash val="solid"/>
+                      <a:round/>
+                      <a:headEnd type="none" w="med" len="med"/>
+                      <a:tailEnd type="none" w="med" len="med"/>
+                    </a:lnR>
+                    <a:lnT w="9525" cap="flat" cmpd="sng" algn="ctr">
+                      <a:solidFill>
+                        <a:schemeClr val="accent6">
+                          <a:alpha val="25000"/>
+                        </a:schemeClr>
+                      </a:solidFill>
+                      <a:prstDash val="solid"/>
+                      <a:round/>
+                      <a:headEnd type="none" w="med" len="med"/>
+                      <a:tailEnd type="none" w="med" len="med"/>
+                    </a:lnT>
+                    <a:lnB w="9525" cap="flat" cmpd="sng" algn="ctr">
+                      <a:solidFill>
+                        <a:schemeClr val="accent6">
+                          <a:alpha val="25000"/>
+                        </a:schemeClr>
+                      </a:solidFill>
+                      <a:prstDash val="solid"/>
+                      <a:round/>
+                      <a:headEnd type="none" w="med" len="med"/>
+                      <a:tailEnd type="none" w="med" len="med"/>
+                    </a:lnB>
+                    <a:solidFill>
+                      <a:schemeClr val="accent6">
+                        <a:alpha val="6000"/>
+                      </a:schemeClr>
+                    </a:solidFill>
+                  </a:tcPr>
+                </a:tc>
+                <a:tc>
+                  <a:txBody>
+                    <a:bodyPr/>
+                    <a:lstStyle/>
+                    <a:p>
+                      <a:pPr marL="0" indent="0">
+                        <a:buNone/>
+                      </a:pPr>
+                      <a:r>
+                        <a:rPr sz="1400" lang="ja-JP" dirty="0">
+                          <a:solidFill>
+                            <a:schemeClr val="tx2"/>
+                          </a:solidFill>
+                          <a:latin typeface="+mn-lt"/>
+                          <a:ea typeface="+mn-ea"/>
+                          <a:cs typeface="+mn-cs"/>
+                        </a:rPr>
+                        <a:t>本文の色で表示されます</a:t>
+                      </a:r>
+                    </a:p>
+                  </a:txBody>
+                  <a:tcPr marL="146304" marR="146304" marT="36576" marB="36576" anchor="ctr">
+                    <a:lnL w="9525" cap="flat" cmpd="sng" algn="ctr">
+                      <a:noFill/>
+                      <a:prstDash val="solid"/>
+                      <a:round/>
+                      <a:headEnd type="none" w="med" len="med"/>
+                      <a:tailEnd type="none" w="med" len="med"/>
+                    </a:lnL>
+                    <a:lnR w="9525" cap="flat" cmpd="sng" algn="ctr">
+                      <a:noFill/>
+                      <a:prstDash val="solid"/>
+                      <a:round/>
+                      <a:headEnd type="none" w="med" len="med"/>
+                      <a:tailEnd type="none" w="med" len="med"/>
+                    </a:lnR>
+                    <a:lnT w="9525" cap="flat" cmpd="sng" algn="ctr">
+                      <a:solidFill>
+                        <a:schemeClr val="accent6">
+                          <a:alpha val="25000"/>
+                        </a:schemeClr>
+                      </a:solidFill>
+                      <a:prstDash val="solid"/>
+                      <a:round/>
+                      <a:headEnd type="none" w="med" len="med"/>
+                      <a:tailEnd type="none" w="med" len="med"/>
+                    </a:lnT>
+                    <a:lnB w="9525" cap="flat" cmpd="sng" algn="ctr">
+                      <a:solidFill>
+                        <a:schemeClr val="accent6">
+                          <a:alpha val="25000"/>
+                        </a:schemeClr>
+                      </a:solidFill>
+                      <a:prstDash val="solid"/>
+                      <a:round/>
+                      <a:headEnd type="none" w="med" len="med"/>
+                      <a:tailEnd type="none" w="med" len="med"/>
+                    </a:lnB>
+                    <a:solidFill>
+                      <a:schemeClr val="accent6">
+                        <a:alpha val="6000"/>
+                      </a:schemeClr>
+                    </a:solidFill>
+                  </a:tcPr>
+                </a:tc>
+              </a:tr>
+              <a:tr h="384048">
+                <a:tc>
+                  <a:txBody>
+                    <a:bodyPr/>
+                    <a:lstStyle/>
+                    <a:p>
+                      <a:pPr marL="0" indent="0">
+                        <a:buNone/>
+                      </a:pPr>
+                      <a:r>
+                        <a:rPr sz="1400" b="1" lang="ja-JP" dirty="0">
+                          <a:solidFill>
+                            <a:schemeClr val="accent1"/>
+                          </a:solidFill>
+                          <a:latin typeface="+mn-lt"/>
+                          <a:ea typeface="+mn-ea"/>
+                          <a:cs typeface="+mn-cs"/>
+                        </a:rPr>
+                        <a:t>行数</a:t>
+                      </a:r>
+                    </a:p>
+                  </a:txBody>
+                  <a:tcPr marL="146304" marR="146304" marT="36576" marB="36576" anchor="ctr">
+                    <a:lnL w="9525" cap="flat" cmpd="sng" algn="ctr">
+                      <a:noFill/>
+                      <a:prstDash val="solid"/>
+                      <a:round/>
+                      <a:headEnd type="none" w="med" len="med"/>
+                      <a:tailEnd type="none" w="med" len="med"/>
+                    </a:lnL>
+                    <a:lnR w="9525" cap="flat" cmpd="sng" algn="ctr">
+                      <a:noFill/>
+                      <a:prstDash val="solid"/>
+                      <a:round/>
+                      <a:headEnd type="none" w="med" len="med"/>
+                      <a:tailEnd type="none" w="med" len="med"/>
+                    </a:lnR>
+                    <a:lnT w="9525" cap="flat" cmpd="sng" algn="ctr">
+                      <a:solidFill>
+                        <a:schemeClr val="accent6">
+                          <a:alpha val="25000"/>
+                        </a:schemeClr>
+                      </a:solidFill>
+                      <a:prstDash val="solid"/>
+                      <a:round/>
+                      <a:headEnd type="none" w="med" len="med"/>
+                      <a:tailEnd type="none" w="med" len="med"/>
+                    </a:lnT>
+                    <a:lnB w="9525" cap="flat" cmpd="sng" algn="ctr">
+                      <a:solidFill>
+                        <a:schemeClr val="accent6">
+                          <a:alpha val="25000"/>
+                        </a:schemeClr>
+                      </a:solidFill>
+                      <a:prstDash val="solid"/>
+                      <a:round/>
+                      <a:headEnd type="none" w="med" len="med"/>
+                      <a:tailEnd type="none" w="med" len="med"/>
+                    </a:lnB>
+                    <a:solidFill>
+                      <a:schemeClr val="bg1"/>
+                    </a:solidFill>
+                  </a:tcPr>
+                </a:tc>
+                <a:tc>
+                  <a:txBody>
+                    <a:bodyPr/>
+                    <a:lstStyle/>
+                    <a:p>
+                      <a:pPr marL="0" indent="0">
+                        <a:buNone/>
+                      </a:pPr>
+                      <a:r>
+                        <a:rPr sz="1400" lang="ja-JP" dirty="0">
+                          <a:solidFill>
+                            <a:schemeClr val="tx2"/>
+                          </a:solidFill>
+                          <a:latin typeface="+mn-lt"/>
+                          <a:ea typeface="+mn-ea"/>
+                          <a:cs typeface="+mn-cs"/>
+                        </a:rPr>
+                        <a:t>ヘッダーを含めて5行前後が目安です</a:t>
+                      </a:r>
+                    </a:p>
+                  </a:txBody>
+                  <a:tcPr marL="146304" marR="146304" marT="36576" marB="36576" anchor="ctr">
+                    <a:lnL w="9525" cap="flat" cmpd="sng" algn="ctr">
+                      <a:noFill/>
+                      <a:prstDash val="solid"/>
+                      <a:round/>
+                      <a:headEnd type="none" w="med" len="med"/>
+                      <a:tailEnd type="none" w="med" len="med"/>
+                    </a:lnL>
+                    <a:lnR w="9525" cap="flat" cmpd="sng" algn="ctr">
+                      <a:noFill/>
+                      <a:prstDash val="solid"/>
+                      <a:round/>
+                      <a:headEnd type="none" w="med" len="med"/>
+                      <a:tailEnd type="none" w="med" len="med"/>
+                    </a:lnR>
+                    <a:lnT w="9525" cap="flat" cmpd="sng" algn="ctr">
+                      <a:solidFill>
+                        <a:schemeClr val="accent6">
+                          <a:alpha val="25000"/>
+                        </a:schemeClr>
+                      </a:solidFill>
+                      <a:prstDash val="solid"/>
+                      <a:round/>
+                      <a:headEnd type="none" w="med" len="med"/>
+                      <a:tailEnd type="none" w="med" len="med"/>
+                    </a:lnT>
+                    <a:lnB w="9525" cap="flat" cmpd="sng" algn="ctr">
+                      <a:solidFill>
+                        <a:schemeClr val="accent6">
+                          <a:alpha val="25000"/>
+                        </a:schemeClr>
+                      </a:solidFill>
+                      <a:prstDash val="solid"/>
+                      <a:round/>
+                      <a:headEnd type="none" w="med" len="med"/>
+                      <a:tailEnd type="none" w="med" len="med"/>
+                    </a:lnB>
+                    <a:solidFill>
+                      <a:schemeClr val="bg1"/>
+                    </a:solidFill>
+                  </a:tcPr>
+                </a:tc>
+              </a:tr>
+            </a:tbl>
+          </a:graphicData>
+        </a:graphic>
+      </p:graphicFrame>
+      <p:sp>
+        <p:nvSpPr>
+          <p:cNvPr id="4" name="Footer Placeholder"/>
+          <p:cNvSpPr>
+            <a:spLocks noGrp="1"/>
+          </p:cNvSpPr>
+          <p:nvPr>
+            <p:ph type="ftr" sz="quarter" idx="11"/>
+          </p:nvPr>
+        </p:nvSpPr>
+        <p:spPr>
+          <a:xfrm>
+            <a:off x="761695" y="6172200"/>
+            <a:ext cx="6400800" cy="274320"/>
+          </a:xfrm>
+          <a:prstGeom prst="rect">
+            <a:avLst/>
+          </a:prstGeom>
+        </p:spPr>
+        <p:txBody>
+          <a:bodyPr vert="horz" lIns="0" tIns="0" rIns="0" bIns="0" anchor="ctr"/>
+          <a:lstStyle>
+            <a:lvl1pPr marL="0" indent="0" algn="l">
+              <a:lnSpc>
+                <a:spcPct val="112000"/>
+              </a:lnSpc>
+              <a:spcBef>
+                <a:spcPts val="0"/>
+              </a:spcBef>
+              <a:buNone/>
+              <a:defRPr sz="1000" b="0" kern="1200" spc="60">
+                <a:solidFill>
+                  <a:schemeClr val="accent6"/>
+                </a:solidFill>
+                <a:latin typeface="+mn-lt"/>
+                <a:ea typeface="+mn-ea"/>
+                <a:cs typeface="+mn-cs"/>
+              </a:defRPr>
+            </a:lvl1pPr>
+            <a:lvl2pPr marL="400050" indent="-285750" algn="l">
+              <a:lnSpc>
+                <a:spcPct val="112000"/>
+              </a:lnSpc>
+              <a:spcBef>
+                <a:spcPts val="600"/>
+              </a:spcBef>
+              <a:buClr>
+                <a:schemeClr val="accent6"/>
+              </a:buClr>
+              <a:buSzPct val="90000"/>
+              <a:buFont typeface="Arial" panose="020B0604020202020204" pitchFamily="34" charset="0"/>
+              <a:buChar char="–"/>
+              <a:defRPr sz="1000" b="0" kern="1200">
+                <a:solidFill>
+                  <a:schemeClr val="accent6"/>
+                </a:solidFill>
+                <a:latin typeface="+mn-lt"/>
+                <a:ea typeface="+mn-ea"/>
+                <a:cs typeface="+mn-cs"/>
+              </a:defRPr>
+            </a:lvl2pPr>
+          </a:lstStyle>
+          <a:p>
+            <a:r>
+              <a:rPr lang="ja-JP" dirty="0"/>
+              <a:t/>
+            </a:r>
+            <a:endParaRPr lang="ja-JP" dirty="0"/>
+          </a:p>
+        </p:txBody>
+      </p:sp>
+      <p:sp>
+        <p:nvSpPr>
+          <p:cNvPr id="5" name="Slide Number Placeholder"/>
+          <p:cNvSpPr>
+            <a:spLocks noGrp="1"/>
+          </p:cNvSpPr>
+          <p:nvPr>
+            <p:ph type="sldNum" sz="quarter" idx="12"/>
+          </p:nvPr>
+        </p:nvSpPr>
+        <p:spPr>
+          <a:xfrm>
+            <a:off x="10515905" y="6172200"/>
+            <a:ext cx="914400" cy="274320"/>
+          </a:xfrm>
+          <a:prstGeom prst="rect">
+            <a:avLst/>
+          </a:prstGeom>
+        </p:spPr>
+        <p:txBody>
+          <a:bodyPr vert="horz" lIns="0" tIns="0" rIns="0" bIns="0" anchor="ctr"/>
+          <a:lstStyle>
+            <a:lvl1pPr marL="0" indent="0" algn="r">
+              <a:lnSpc>
+                <a:spcPct val="112000"/>
+              </a:lnSpc>
+              <a:spcBef>
+                <a:spcPts val="0"/>
+              </a:spcBef>
+              <a:buNone/>
+              <a:defRPr sz="1000" b="0" kern="1200">
+                <a:solidFill>
+                  <a:schemeClr val="accent6"/>
+                </a:solidFill>
+                <a:latin typeface="+mn-lt"/>
+                <a:ea typeface="+mn-ea"/>
+                <a:cs typeface="+mn-cs"/>
+              </a:defRPr>
+            </a:lvl1pPr>
+            <a:lvl2pPr marL="400050" indent="-285750" algn="r">
+              <a:lnSpc>
+                <a:spcPct val="112000"/>
+              </a:lnSpc>
+              <a:spcBef>
+                <a:spcPts val="600"/>
+              </a:spcBef>
+              <a:buClr>
+                <a:schemeClr val="accent6"/>
+              </a:buClr>
+              <a:buSzPct val="90000"/>
+              <a:buFont typeface="Arial" panose="020B0604020202020204" pitchFamily="34" charset="0"/>
+              <a:buChar char="–"/>
+              <a:defRPr sz="1000" b="0" kern="1200">
+                <a:solidFill>
+                  <a:schemeClr val="accent6"/>
+                </a:solidFill>
+                <a:latin typeface="+mn-lt"/>
+                <a:ea typeface="+mn-ea"/>
+                <a:cs typeface="+mn-cs"/>
+              </a:defRPr>
+            </a:lvl2pPr>
+          </a:lstStyle>
+          <a:p>
+            <a:pPr algn="r"/>
+            <a:fld id="{A6600FCE-F2AA-4203-896F-1E16607A58F5}" type="slidenum">
+              <a:rPr lang="ja-JP" smtClean="0"/>
+              <a:t>2</a:t>
+            </a:fld>
+            <a:endParaRPr lang="ja-JP" dirty="0"/>
+          </a:p>
+        </p:txBody>
+      </p:sp>
+    </p:spTree>
+  </p:cSld>
+  <p:clrMapOvr>
+    <a:masterClrMapping/>
+  </p:clrMapOvr>
+</p:sld>
+</file>
+
+<file path=ppt/slides/slide4.xml><?xml version="1.0" encoding="utf-8"?>
+<p:sld xmlns:a="http://schemas.openxmlformats.org/drawingml/2006/main" xmlns:p="http://schemas.openxmlformats.org/presentationml/2006/main" xmlns:r="http://schemas.openxmlformats.org/officeDocument/2006/relationships">
+  <p:cSld>
+    <p:spTree>
+      <p:nvGrpSpPr>
+        <p:cNvPr id="1" name=""/>
+        <p:cNvGrpSpPr/>
+        <p:nvPr/>
+      </p:nvGrpSpPr>
+      <p:grpSpPr/>
+      <p:sp>
+        <p:nvSpPr>
+          <p:cNvPr id="2" name="Title 1"/>
+          <p:cNvSpPr>
+            <a:spLocks noGrp="1"/>
+          </p:cNvSpPr>
+          <p:nvPr>
+            <p:ph type="title"/>
+          </p:nvPr>
+        </p:nvSpPr>
+        <p:spPr/>
+        <p:txBody>
+          <a:bodyPr/>
+          <a:lstStyle/>
+          <a:p>
+            <a:r>
+              <a:rPr lang="ja-JP" dirty="0">
+                <a:latin typeface="+mj-lt"/>
+                <a:ea typeface="+mj-ea"/>
+                <a:cs typeface="+mj-cs"/>
+              </a:rPr>
+              <a:t>セクション見出し</a:t>
+            </a:r>
+          </a:p>
+        </p:txBody>
+      </p:sp>
+      <p:sp>
+        <p:nvSpPr>
+          <p:cNvPr id="3" name="Text Placeholder 2"/>
+          <p:cNvSpPr>
+            <a:spLocks noGrp="1"/>
+          </p:cNvSpPr>
+          <p:nvPr>
+            <p:ph type="body" idx="1"/>
+          </p:nvPr>
+        </p:nvSpPr>
+        <p:spPr/>
+        <p:txBody>
+          <a:bodyPr/>
+          <a:lstStyle/>
+          <a:p>
+            <a:pPr/>
+            <a:r>
+              <a:rPr sz="1800" lang="ja-JP" dirty="0">
+                <a:latin typeface="+mn-lt"/>
+                <a:ea typeface="+mn-ea"/>
+                <a:cs typeface="+mn-cs"/>
+              </a:rPr>
+              <a:t>章の区切りに使います</a:t>
+            </a:r>
+          </a:p>
+        </p:txBody>
+      </p:sp>
+      <p:sp>
+        <p:nvSpPr>
+          <p:cNvPr id="4" name="Footer Placeholder"/>
+          <p:cNvSpPr>
+            <a:spLocks noGrp="1"/>
+          </p:cNvSpPr>
+          <p:nvPr>
+            <p:ph type="ftr" sz="quarter" idx="11"/>
+          </p:nvPr>
+        </p:nvSpPr>
+        <p:spPr>
+          <a:xfrm>
+            <a:off x="761695" y="6172200"/>
+            <a:ext cx="6400800" cy="274320"/>
+          </a:xfrm>
+          <a:prstGeom prst="rect">
+            <a:avLst/>
+          </a:prstGeom>
+        </p:spPr>
+        <p:txBody>
+          <a:bodyPr vert="horz" lIns="0" tIns="0" rIns="0" bIns="0" anchor="ctr"/>
+          <a:lstStyle>
+            <a:lvl1pPr marL="0" indent="0" algn="l">
+              <a:lnSpc>
+                <a:spcPct val="112000"/>
+              </a:lnSpc>
+              <a:spcBef>
+                <a:spcPts val="0"/>
+              </a:spcBef>
+              <a:buNone/>
+              <a:defRPr sz="1000" b="0" kern="1200" spc="60">
+                <a:solidFill>
+                  <a:schemeClr val="accent6"/>
+                </a:solidFill>
+                <a:latin typeface="+mn-lt"/>
+                <a:ea typeface="+mn-ea"/>
+                <a:cs typeface="+mn-cs"/>
+              </a:defRPr>
+            </a:lvl1pPr>
+            <a:lvl2pPr marL="400050" indent="-285750" algn="l">
+              <a:lnSpc>
+                <a:spcPct val="112000"/>
+              </a:lnSpc>
+              <a:spcBef>
+                <a:spcPts val="600"/>
+              </a:spcBef>
+              <a:buClr>
+                <a:schemeClr val="accent6"/>
+              </a:buClr>
+              <a:buSzPct val="90000"/>
+              <a:buFont typeface="Arial" panose="020B0604020202020204" pitchFamily="34" charset="0"/>
+              <a:buChar char="–"/>
+              <a:defRPr sz="1000" b="0" kern="1200">
+                <a:solidFill>
+                  <a:schemeClr val="accent6"/>
+                </a:solidFill>
+                <a:latin typeface="+mn-lt"/>
+                <a:ea typeface="+mn-ea"/>
+                <a:cs typeface="+mn-cs"/>
+              </a:defRPr>
+            </a:lvl2pPr>
+          </a:lstStyle>
+          <a:p>
+            <a:r>
+              <a:rPr lang="ja-JP" dirty="0"/>
+              <a:t/>
+            </a:r>
+            <a:endParaRPr lang="ja-JP" dirty="0"/>
+          </a:p>
+        </p:txBody>
+      </p:sp>
+      <p:sp>
+        <p:nvSpPr>
+          <p:cNvPr id="5" name="Slide Number Placeholder"/>
+          <p:cNvSpPr>
+            <a:spLocks noGrp="1"/>
+          </p:cNvSpPr>
+          <p:nvPr>
+            <p:ph type="sldNum" sz="quarter" idx="12"/>
+          </p:nvPr>
+        </p:nvSpPr>
+        <p:spPr>
+          <a:xfrm>
+            <a:off x="10515905" y="6172200"/>
+            <a:ext cx="914400" cy="274320"/>
+          </a:xfrm>
+          <a:prstGeom prst="rect">
+            <a:avLst/>
+          </a:prstGeom>
+        </p:spPr>
+        <p:txBody>
+          <a:bodyPr vert="horz" lIns="0" tIns="0" rIns="0" bIns="0" anchor="ctr"/>
+          <a:lstStyle>
+            <a:lvl1pPr marL="0" indent="0" algn="r">
+              <a:lnSpc>
+                <a:spcPct val="112000"/>
+              </a:lnSpc>
+              <a:spcBef>
+                <a:spcPts val="0"/>
+              </a:spcBef>
+              <a:buNone/>
+              <a:defRPr sz="1000" b="0" kern="1200">
+                <a:solidFill>
+                  <a:schemeClr val="accent6"/>
+                </a:solidFill>
+                <a:latin typeface="+mn-lt"/>
+                <a:ea typeface="+mn-ea"/>
+                <a:cs typeface="+mn-cs"/>
+              </a:defRPr>
+            </a:lvl1pPr>
+            <a:lvl2pPr marL="400050" indent="-285750" algn="r">
+              <a:lnSpc>
+                <a:spcPct val="112000"/>
+              </a:lnSpc>
+              <a:spcBef>
+                <a:spcPts val="600"/>
+              </a:spcBef>
+              <a:buClr>
+                <a:schemeClr val="accent6"/>
+              </a:buClr>
+              <a:buSzPct val="90000"/>
+              <a:buFont typeface="Arial" panose="020B0604020202020204" pitchFamily="34" charset="0"/>
+              <a:buChar char="–"/>
+              <a:defRPr sz="1000" b="0" kern="1200">
+                <a:solidFill>
+                  <a:schemeClr val="accent6"/>
+                </a:solidFill>
+                <a:latin typeface="+mn-lt"/>
+                <a:ea typeface="+mn-ea"/>
+                <a:cs typeface="+mn-cs"/>
+              </a:defRPr>
+            </a:lvl2pPr>
+          </a:lstStyle>
+          <a:p>
+            <a:pPr algn="r"/>
+            <a:fld id="{73F2A692-5056-4689-83E1-A98962D277C1}" type="slidenum">
+              <a:rPr lang="ja-JP" smtClean="0"/>
+              <a:t>2</a:t>
+            </a:fld>
+            <a:endParaRPr lang="ja-JP" dirty="0"/>
+          </a:p>
+        </p:txBody>
+      </p:sp>
+    </p:spTree>
+  </p:cSld>
+  <p:clrMapOvr>
+    <a:masterClrMapping/>
+  </p:clrMapOvr>
+</p:sld>
+</file>
+
+<file path=ppt/slides/slide5.xml><?xml version="1.0" encoding="utf-8"?>
+<p:sld xmlns:a="http://schemas.openxmlformats.org/drawingml/2006/main" xmlns:p="http://schemas.openxmlformats.org/presentationml/2006/main" xmlns:r="http://schemas.openxmlformats.org/officeDocument/2006/relationships">
+  <p:cSld>
+    <p:spTree>
+      <p:nvGrpSpPr>
+        <p:cNvPr id="1" name=""/>
+        <p:cNvGrpSpPr/>
+        <p:nvPr/>
+      </p:nvGrpSpPr>
+      <p:grpSpPr/>
+      <p:sp>
+        <p:nvSpPr>
+          <p:cNvPr id="2" name="Title 1"/>
+          <p:cNvSpPr>
+            <a:spLocks noGrp="1"/>
+          </p:cNvSpPr>
+          <p:nvPr>
+            <p:ph type="title"/>
+          </p:nvPr>
+        </p:nvSpPr>
+        <p:spPr/>
+        <p:txBody>
+          <a:bodyPr/>
+          <a:lstStyle/>
+          <a:p>
+            <a:r>
+              <a:rPr lang="ja-JP" dirty="0">
+                <a:latin typeface="+mj-lt"/>
+                <a:ea typeface="+mj-ea"/>
+                <a:cs typeface="+mj-cs"/>
+              </a:rPr>
+              <a:t>ご清聴ありがとうございました</a:t>
+            </a:r>
+          </a:p>
+        </p:txBody>
+      </p:sp>
+      <p:sp>
+        <p:nvSpPr>
+          <p:cNvPr id="3" name="Text Placeholder 2"/>
+          <p:cNvSpPr>
+            <a:spLocks noGrp="1"/>
+          </p:cNvSpPr>
+          <p:nvPr>
+            <p:ph type="body" idx="1"/>
+          </p:nvPr>
+        </p:nvSpPr>
+        <p:spPr/>
+        <p:txBody>
+          <a:bodyPr/>
+          <a:lstStyle/>
+          <a:p>
+            <a:pPr/>
+            <a:r>
+              <a:rPr sz="1800" lang="ja-JP" dirty="0">
+                <a:latin typeface="+mn-lt"/>
+                <a:ea typeface="+mn-ea"/>
+                <a:cs typeface="+mn-cs"/>
+              </a:rPr>
+              <a:t>お問い合わせ先などを書きます</a:t>
+            </a:r>
+          </a:p>
+        </p:txBody>
+      </p:sp>
+      <p:sp>
+        <p:nvSpPr>
+          <p:cNvPr id="4" name="Footer Placeholder"/>
+          <p:cNvSpPr>
+            <a:spLocks noGrp="1"/>
+          </p:cNvSpPr>
+          <p:nvPr>
+            <p:ph type="ftr" sz="quarter" idx="11"/>
+          </p:nvPr>
+        </p:nvSpPr>
+        <p:spPr>
+          <a:xfrm>
+            <a:off x="761695" y="6172200"/>
+            <a:ext cx="6400800" cy="274320"/>
+          </a:xfrm>
+          <a:prstGeom prst="rect">
+            <a:avLst/>
+          </a:prstGeom>
+        </p:spPr>
+        <p:txBody>
+          <a:bodyPr vert="horz" lIns="0" tIns="0" rIns="0" bIns="0" anchor="ctr"/>
+          <a:lstStyle>
+            <a:lvl1pPr marL="0" indent="0" algn="l">
+              <a:lnSpc>
+                <a:spcPct val="112000"/>
+              </a:lnSpc>
+              <a:spcBef>
+                <a:spcPts val="0"/>
+              </a:spcBef>
+              <a:buNone/>
+              <a:defRPr sz="1000" b="0" kern="1200" spc="60">
+                <a:solidFill>
+                  <a:schemeClr val="bg1">
+                    <a:alpha val="75000"/>
+                  </a:schemeClr>
+                </a:solidFill>
+                <a:latin typeface="+mn-lt"/>
+                <a:ea typeface="+mn-ea"/>
+                <a:cs typeface="+mn-cs"/>
+              </a:defRPr>
+            </a:lvl1pPr>
+            <a:lvl2pPr marL="400050" indent="-285750" algn="l">
+              <a:lnSpc>
+                <a:spcPct val="112000"/>
+              </a:lnSpc>
+              <a:spcBef>
+                <a:spcPts val="600"/>
+              </a:spcBef>
+              <a:buClr>
+                <a:schemeClr val="accent6"/>
+              </a:buClr>
+              <a:buSzPct val="90000"/>
+              <a:buFont typeface="Arial" panose="020B0604020202020204" pitchFamily="34" charset="0"/>
+              <a:buChar char="–"/>
+              <a:defRPr sz="1000" b="0" kern="1200">
+                <a:solidFill>
+                  <a:schemeClr val="accent6"/>
+                </a:solidFill>
+                <a:latin typeface="+mn-lt"/>
+                <a:ea typeface="+mn-ea"/>
+                <a:cs typeface="+mn-cs"/>
+              </a:defRPr>
+            </a:lvl2pPr>
+          </a:lstStyle>
+          <a:p>
+            <a:r>
+              <a:rPr lang="ja-JP" dirty="0"/>
+              <a:t/>
+            </a:r>
+            <a:endParaRPr lang="ja-JP" dirty="0"/>
+          </a:p>
+        </p:txBody>
+      </p:sp>
+      <p:sp>
+        <p:nvSpPr>
+          <p:cNvPr id="5" name="Slide Number Placeholder"/>
+          <p:cNvSpPr>
+            <a:spLocks noGrp="1"/>
+          </p:cNvSpPr>
+          <p:nvPr>
+            <p:ph type="sldNum" sz="quarter" idx="12"/>
+          </p:nvPr>
+        </p:nvSpPr>
+        <p:spPr>
+          <a:xfrm>
+            <a:off x="10515905" y="6172200"/>
+            <a:ext cx="914400" cy="274320"/>
+          </a:xfrm>
+          <a:prstGeom prst="rect">
+            <a:avLst/>
+          </a:prstGeom>
+        </p:spPr>
+        <p:txBody>
+          <a:bodyPr vert="horz" lIns="0" tIns="0" rIns="0" bIns="0" anchor="ctr"/>
+          <a:lstStyle>
+            <a:lvl1pPr marL="0" indent="0" algn="r">
+              <a:lnSpc>
+                <a:spcPct val="112000"/>
+              </a:lnSpc>
+              <a:spcBef>
+                <a:spcPts val="0"/>
+              </a:spcBef>
+              <a:buNone/>
+              <a:defRPr sz="1000" b="0" kern="1200">
+                <a:solidFill>
+                  <a:schemeClr val="bg1">
+                    <a:alpha val="75000"/>
+                  </a:schemeClr>
+                </a:solidFill>
+                <a:latin typeface="+mn-lt"/>
+                <a:ea typeface="+mn-ea"/>
+                <a:cs typeface="+mn-cs"/>
+              </a:defRPr>
+            </a:lvl1pPr>
+            <a:lvl2pPr marL="400050" indent="-285750" algn="r">
+              <a:lnSpc>
+                <a:spcPct val="112000"/>
+              </a:lnSpc>
+              <a:spcBef>
+                <a:spcPts val="600"/>
+              </a:spcBef>
+              <a:buClr>
+                <a:schemeClr val="accent6"/>
+              </a:buClr>
+              <a:buSzPct val="90000"/>
+              <a:buFont typeface="Arial" panose="020B0604020202020204" pitchFamily="34" charset="0"/>
+              <a:buChar char="–"/>
+              <a:defRPr sz="1000" b="0" kern="1200">
+                <a:solidFill>
+                  <a:schemeClr val="accent6"/>
+                </a:solidFill>
+                <a:latin typeface="+mn-lt"/>
+                <a:ea typeface="+mn-ea"/>
+                <a:cs typeface="+mn-cs"/>
+              </a:defRPr>
+            </a:lvl2pPr>
+          </a:lstStyle>
+          <a:p>
+            <a:pPr algn="r"/>
+            <a:fld id="{6358105C-DA2C-45B1-A81D-568F14B95AA7}" type="slidenum">
+              <a:rPr lang="ja-JP" smtClean="0"/>
+              <a:t>19</a:t>
+            </a:fld>
+            <a:endParaRPr lang="ja-JP" dirty="0"/>
+          </a:p>
+        </p:txBody>
+      </p:sp>
+    </p:spTree>
+  </p:cSld>
+  <p:clrMapOvr>
+    <a:masterClrMapping/>
+  </p:clrMapOvr>
+</p:sld>
+</file>
+
 <file path=ppt/theme/theme1.xml><?xml version="1.0" encoding="utf-8"?>
 <a:theme xmlns:a="http://schemas.openxmlformats.org/drawingml/2006/main" name="Kotonara">
   <a:themeElements>
@@ -2930,7 +4829,7 @@
         <a:srgbClr val="EADECC"/>
       </a:lt2>
       <a:accent1>
-        <a:srgbClr val="1A832A"/>
+        <a:srgbClr val="4D9622"/>
       </a:accent1>
       <a:accent2>
         <a:srgbClr val="4169E1"/>
@@ -3061,7 +4960,7 @@
         <a:srgbClr val="EADECC"/>
       </a:lt2>
       <a:accent1>
-        <a:srgbClr val="1A832A"/>
+        <a:srgbClr val="4D9622"/>
       </a:accent1>
       <a:accent2>
         <a:srgbClr val="4169E1"/>

</xml_diff>